<commit_message>
Reporte 26 de marzo
</commit_message>
<xml_diff>
--- a/Reporte 250326.pptx
+++ b/Reporte 250326.pptx
@@ -6181,10 +6181,10 @@
       </p:sp>
       <p:pic>
         <p:nvPicPr>
-          <p:cNvPr id="3" name="Imagen 2">
+          <p:cNvPr id="4" name="Imagen 3">
             <a:extLst>
               <a:ext uri="{FF2B5EF4-FFF2-40B4-BE49-F238E27FC236}">
-                <a16:creationId xmlns:a16="http://schemas.microsoft.com/office/drawing/2014/main" id="{84E5858D-1857-D39A-A1CC-F3743999A8AC}"/>
+                <a16:creationId xmlns:a16="http://schemas.microsoft.com/office/drawing/2014/main" id="{A4C9F752-F248-B2EA-C35B-FE6787139155}"/>
               </a:ext>
             </a:extLst>
           </p:cNvPr>
@@ -6201,8 +6201,8 @@
         </p:blipFill>
         <p:spPr>
           <a:xfrm>
-            <a:off x="0" y="418813"/>
-            <a:ext cx="9144000" cy="4305873"/>
+            <a:off x="0" y="398717"/>
+            <a:ext cx="9144000" cy="4346066"/>
           </a:xfrm>
           <a:prstGeom prst="rect">
             <a:avLst/>
@@ -6279,10 +6279,10 @@
       </p:sp>
       <p:pic>
         <p:nvPicPr>
-          <p:cNvPr id="4" name="Imagen 3">
+          <p:cNvPr id="5" name="Imagen 4">
             <a:extLst>
               <a:ext uri="{FF2B5EF4-FFF2-40B4-BE49-F238E27FC236}">
-                <a16:creationId xmlns:a16="http://schemas.microsoft.com/office/drawing/2014/main" id="{A99CF594-82E7-5F74-EA57-01B96A2124EE}"/>
+                <a16:creationId xmlns:a16="http://schemas.microsoft.com/office/drawing/2014/main" id="{99AAED57-01A1-C42F-F9A1-BCD38EAE496B}"/>
               </a:ext>
             </a:extLst>
           </p:cNvPr>
@@ -6299,8 +6299,8 @@
         </p:blipFill>
         <p:spPr>
           <a:xfrm>
-            <a:off x="0" y="802852"/>
-            <a:ext cx="9144000" cy="3537796"/>
+            <a:off x="0" y="805295"/>
+            <a:ext cx="9144000" cy="3532909"/>
           </a:xfrm>
           <a:prstGeom prst="rect">
             <a:avLst/>
@@ -6377,10 +6377,10 @@
       </p:sp>
       <p:pic>
         <p:nvPicPr>
-          <p:cNvPr id="3" name="Imagen 2">
+          <p:cNvPr id="4" name="Imagen 3">
             <a:extLst>
               <a:ext uri="{FF2B5EF4-FFF2-40B4-BE49-F238E27FC236}">
-                <a16:creationId xmlns:a16="http://schemas.microsoft.com/office/drawing/2014/main" id="{46E62471-C098-FBD8-556C-B0BE2D86A6B0}"/>
+                <a16:creationId xmlns:a16="http://schemas.microsoft.com/office/drawing/2014/main" id="{D2E99A22-4620-E7E6-EBD6-FA5DD3AC93AA}"/>
               </a:ext>
             </a:extLst>
           </p:cNvPr>
@@ -6397,8 +6397,8 @@
         </p:blipFill>
         <p:spPr>
           <a:xfrm>
-            <a:off x="0" y="1197078"/>
-            <a:ext cx="9144000" cy="2749344"/>
+            <a:off x="0" y="1230188"/>
+            <a:ext cx="9144000" cy="2683123"/>
           </a:xfrm>
           <a:prstGeom prst="rect">
             <a:avLst/>
@@ -6475,10 +6475,10 @@
       </p:sp>
       <p:pic>
         <p:nvPicPr>
-          <p:cNvPr id="4" name="Imagen 3">
+          <p:cNvPr id="3" name="Imagen 2">
             <a:extLst>
               <a:ext uri="{FF2B5EF4-FFF2-40B4-BE49-F238E27FC236}">
-                <a16:creationId xmlns:a16="http://schemas.microsoft.com/office/drawing/2014/main" id="{67531507-D663-3C12-6264-96903662EF84}"/>
+                <a16:creationId xmlns:a16="http://schemas.microsoft.com/office/drawing/2014/main" id="{E61BBA5E-61BF-A3A4-3FFC-54E367DDD1D1}"/>
               </a:ext>
             </a:extLst>
           </p:cNvPr>
@@ -6495,8 +6495,8 @@
         </p:blipFill>
         <p:spPr>
           <a:xfrm>
-            <a:off x="0" y="1231416"/>
-            <a:ext cx="9144000" cy="2680668"/>
+            <a:off x="0" y="1294019"/>
+            <a:ext cx="9144000" cy="2555462"/>
           </a:xfrm>
           <a:prstGeom prst="rect">
             <a:avLst/>
@@ -6579,10 +6579,10 @@
       </p:sp>
       <p:pic>
         <p:nvPicPr>
-          <p:cNvPr id="4" name="Imagen 3">
+          <p:cNvPr id="3" name="Imagen 2">
             <a:extLst>
               <a:ext uri="{FF2B5EF4-FFF2-40B4-BE49-F238E27FC236}">
-                <a16:creationId xmlns:a16="http://schemas.microsoft.com/office/drawing/2014/main" id="{4C3DD3D1-A11E-4BBC-F790-A66C08D4F24F}"/>
+                <a16:creationId xmlns:a16="http://schemas.microsoft.com/office/drawing/2014/main" id="{51A1DBF8-738A-7003-E18F-38A717839934}"/>
               </a:ext>
             </a:extLst>
           </p:cNvPr>
@@ -6599,8 +6599,8 @@
         </p:blipFill>
         <p:spPr>
           <a:xfrm>
-            <a:off x="0" y="1403179"/>
-            <a:ext cx="9144000" cy="2337141"/>
+            <a:off x="0" y="712970"/>
+            <a:ext cx="9144000" cy="3717560"/>
           </a:xfrm>
           <a:prstGeom prst="rect">
             <a:avLst/>
@@ -6682,10 +6682,10 @@
       </p:sp>
       <p:pic>
         <p:nvPicPr>
-          <p:cNvPr id="3" name="Imagen 2">
+          <p:cNvPr id="4" name="Imagen 3">
             <a:extLst>
               <a:ext uri="{FF2B5EF4-FFF2-40B4-BE49-F238E27FC236}">
-                <a16:creationId xmlns:a16="http://schemas.microsoft.com/office/drawing/2014/main" id="{787B2DE8-52CA-2251-3068-213B8D8D60A1}"/>
+                <a16:creationId xmlns:a16="http://schemas.microsoft.com/office/drawing/2014/main" id="{BB0C6FCF-6BB2-1C90-11C7-E3F887EDC297}"/>
               </a:ext>
             </a:extLst>
           </p:cNvPr>
@@ -6702,8 +6702,8 @@
         </p:blipFill>
         <p:spPr>
           <a:xfrm>
-            <a:off x="0" y="321357"/>
-            <a:ext cx="9144000" cy="4500785"/>
+            <a:off x="537599" y="490247"/>
+            <a:ext cx="8068801" cy="4163006"/>
           </a:xfrm>
           <a:prstGeom prst="rect">
             <a:avLst/>
@@ -7542,10 +7542,10 @@
       </p:sp>
       <p:pic>
         <p:nvPicPr>
-          <p:cNvPr id="4" name="Imagen 3">
+          <p:cNvPr id="5" name="Imagen 4">
             <a:extLst>
               <a:ext uri="{FF2B5EF4-FFF2-40B4-BE49-F238E27FC236}">
-                <a16:creationId xmlns:a16="http://schemas.microsoft.com/office/drawing/2014/main" id="{86DD8DA6-A694-593C-6D20-3EABEAA51B6C}"/>
+                <a16:creationId xmlns:a16="http://schemas.microsoft.com/office/drawing/2014/main" id="{1C5230EE-89F1-505E-6FCA-F0BC7BE9D539}"/>
               </a:ext>
             </a:extLst>
           </p:cNvPr>
@@ -7562,8 +7562,8 @@
         </p:blipFill>
         <p:spPr>
           <a:xfrm>
-            <a:off x="0" y="355561"/>
-            <a:ext cx="9144000" cy="4432378"/>
+            <a:off x="0" y="359165"/>
+            <a:ext cx="9144000" cy="4425169"/>
           </a:xfrm>
           <a:prstGeom prst="rect">
             <a:avLst/>
@@ -7640,10 +7640,10 @@
       </p:sp>
       <p:pic>
         <p:nvPicPr>
-          <p:cNvPr id="3" name="Imagen 2">
+          <p:cNvPr id="4" name="Imagen 3">
             <a:extLst>
               <a:ext uri="{FF2B5EF4-FFF2-40B4-BE49-F238E27FC236}">
-                <a16:creationId xmlns:a16="http://schemas.microsoft.com/office/drawing/2014/main" id="{87F6BEBB-5B5D-4B26-1AFD-34D6BD4D745E}"/>
+                <a16:creationId xmlns:a16="http://schemas.microsoft.com/office/drawing/2014/main" id="{D1C71A37-DFA7-D049-235B-C04AB0537571}"/>
               </a:ext>
             </a:extLst>
           </p:cNvPr>
@@ -7660,8 +7660,8 @@
         </p:blipFill>
         <p:spPr>
           <a:xfrm>
-            <a:off x="0" y="916544"/>
-            <a:ext cx="9144000" cy="3310411"/>
+            <a:off x="0" y="916885"/>
+            <a:ext cx="9144000" cy="3309730"/>
           </a:xfrm>
           <a:prstGeom prst="rect">
             <a:avLst/>

</xml_diff>